<commit_message>
Standalone risk-ledger page: walk-away-ledger table format, 6 columns
Rebuild the standalone page in the walk-away-ledger table layout (rows =
companies, columns = stages) to demonstrate the risk system in practice and its
evolution. Six columns/headers: company & position, thesis & engagement, the
risk trigger, the disciplined action, outcome, what it taught the system. Two
rows (DistIT — determined-seller origin; Robit — agreement-before-capital),
built from a rows list so more companies can be added. Closer frames the system
as one we both use and keep building.

https://claude.ai/code/session_01HQUpw4QYvApiNnSfGrjnJ2
</commit_message>
<xml_diff>
--- a/Athanase_DistIT_page.pptx
+++ b/Athanase_DistIT_page.pptx
@@ -3193,7 +3193,7 @@
                 </a:solidFill>
                 <a:latin typeface="Arial"/>
               </a:rPr>
-              <a:t>Case studies · Risk discipline</a:t>
+              <a:t>Risk system · In practice</a:t>
             </a:r>
           </a:p>
         </p:txBody>
@@ -3279,7 +3279,7 @@
                 </a:solidFill>
                 <a:latin typeface="Times New Roman"/>
               </a:rPr>
-              <a:t>Two cases, one discipline: when to walk away, and when to sell</a:t>
+              <a:t>The risk ledger: our system in practice — and how it developed</a:t>
             </a:r>
           </a:p>
         </p:txBody>
@@ -3321,7 +3321,7 @@
                 </a:solidFill>
                 <a:latin typeface="Arial"/>
               </a:rPr>
-              <a:t>When we cannot secure alignment we walk away (Robit); when the thesis breaks we sell on the facts, not the share price (DistIT) — and the one mistake we made built the system.</a:t>
+              <a:t>Every engagement tests the risk system, and our mistakes refine it. Each row shows what the system flagged, the disciplined action it forced, the outcome — and what it taught.</a:t>
             </a:r>
           </a:p>
         </p:txBody>
@@ -3370,14 +3370,58 @@
       </p:sp>
       <p:sp>
         <p:nvSpPr>
-          <p:cNvPr id="9" name="TextBox 8"/>
+          <p:cNvPr id="9" name="Rectangle 8"/>
+          <p:cNvSpPr/>
+          <p:nvPr/>
+        </p:nvSpPr>
+        <p:spPr>
+          <a:xfrm>
+            <a:off x="438922" y="2340864"/>
+            <a:ext cx="1499652" cy="536448"/>
+          </a:xfrm>
+          <a:prstGeom prst="rect">
+            <a:avLst/>
+          </a:prstGeom>
+          <a:solidFill>
+            <a:srgbClr val="314359"/>
+          </a:solidFill>
+          <a:ln>
+            <a:noFill/>
+          </a:ln>
+          <a:effectLst/>
+        </p:spPr>
+        <p:style>
+          <a:lnRef idx="1">
+            <a:schemeClr val="accent1"/>
+          </a:lnRef>
+          <a:fillRef idx="3">
+            <a:schemeClr val="accent1"/>
+          </a:fillRef>
+          <a:effectRef idx="2">
+            <a:schemeClr val="accent1"/>
+          </a:effectRef>
+          <a:fontRef idx="minor">
+            <a:schemeClr val="lt1"/>
+          </a:fontRef>
+        </p:style>
+        <p:txBody>
+          <a:bodyPr rtlCol="0" anchor="ctr"/>
+          <a:lstStyle/>
+          <a:p>
+            <a:pPr algn="ctr"/>
+          </a:p>
+        </p:txBody>
+      </p:sp>
+      <p:sp>
+        <p:nvSpPr>
+          <p:cNvPr id="10" name="TextBox 9"/>
           <p:cNvSpPr txBox="1"/>
           <p:nvPr/>
         </p:nvSpPr>
         <p:spPr>
           <a:xfrm>
-            <a:off x="548653" y="2340864"/>
-            <a:ext cx="4279499" cy="4194048"/>
+            <a:off x="512076" y="2340864"/>
+            <a:ext cx="1367975" cy="536448"/>
           </a:xfrm>
           <a:prstGeom prst="rect">
             <a:avLst/>
@@ -3385,117 +3429,85 @@
           <a:noFill/>
         </p:spPr>
         <p:txBody>
-          <a:bodyPr wrap="square" anchor="t" lIns="0" rIns="0" tIns="0" bIns="0">
+          <a:bodyPr wrap="square" anchor="ctr" lIns="0" rIns="0" tIns="0" bIns="0">
             <a:spAutoFit/>
           </a:bodyPr>
           <a:lstStyle/>
           <a:p>
             <a:pPr algn="l">
               <a:lnSpc>
-                <a:spcPct val="110000"/>
+                <a:spcPct val="104000"/>
               </a:lnSpc>
               <a:spcAft>
-                <a:spcPts val="800"/>
+                <a:spcPts val="0"/>
               </a:spcAft>
             </a:pPr>
             <a:r>
-              <a:rPr sz="1000" b="1" i="0">
+              <a:rPr sz="720" b="1" i="0">
                 <a:solidFill>
-                  <a:srgbClr val="314359"/>
+                  <a:srgbClr val="FFFFFF"/>
                 </a:solidFill>
                 <a:latin typeface="Arial"/>
               </a:rPr>
-              <a:t>DISTIT — A THESIS SHIFT, ACTED ON</a:t>
-            </a:r>
-          </a:p>
-          <a:p>
-            <a:pPr algn="l">
-              <a:lnSpc>
-                <a:spcPct val="114000"/>
-              </a:lnSpc>
-              <a:spcAft>
-                <a:spcPts val="800"/>
-              </a:spcAft>
-            </a:pPr>
-            <a:r>
-              <a:rPr sz="1000" b="0" i="0">
-                <a:solidFill>
-                  <a:srgbClr val="0E1620"/>
-                </a:solidFill>
-                <a:latin typeface="Arial"/>
-              </a:rPr>
-              <a:t>Built it (from 2015): bought in and installed a new management team and board, compounding the platform over years.</a:t>
-            </a:r>
-          </a:p>
-          <a:p>
-            <a:pPr algn="l">
-              <a:lnSpc>
-                <a:spcPct val="114000"/>
-              </a:lnSpc>
-              <a:spcAft>
-                <a:spcPts val="800"/>
-              </a:spcAft>
-            </a:pPr>
-            <a:r>
-              <a:rPr sz="1000" b="0" i="0">
-                <a:solidFill>
-                  <a:srgbClr val="0E1620"/>
-                </a:solidFill>
-                <a:latin typeface="Arial"/>
-              </a:rPr>
-              <a:t>Couldn’t block it, so we governed it (2021): we warned against the EFUEL acquisition and held a board seat but could not stop it — so we forced the price down ~40%, from SEK 300m upfront to SEK 180m plus an earn-out, which never paid.</a:t>
-            </a:r>
-          </a:p>
-          <a:p>
-            <a:pPr algn="l">
-              <a:lnSpc>
-                <a:spcPct val="114000"/>
-              </a:lnSpc>
-              <a:spcAft>
-                <a:spcPts val="800"/>
-              </a:spcAft>
-            </a:pPr>
-            <a:r>
-              <a:rPr sz="1000" b="0" i="0">
-                <a:solidFill>
-                  <a:srgbClr val="0E1620"/>
-                </a:solidFill>
-                <a:latin typeface="Arial"/>
-              </a:rPr>
-              <a:t>Acted on the shift: judging the company overvalued, we sold across two blocks — into a rising price, not a falling one — and still made money.</a:t>
-            </a:r>
-          </a:p>
-          <a:p>
-            <a:pPr algn="l">
-              <a:lnSpc>
-                <a:spcPct val="114000"/>
-              </a:lnSpc>
-              <a:spcAft>
-                <a:spcPts val="800"/>
-              </a:spcAft>
-            </a:pPr>
-            <a:r>
-              <a:rPr sz="1000" b="0" i="0">
-                <a:solidFill>
-                  <a:srgbClr val="0E1620"/>
-                </a:solidFill>
-                <a:latin typeface="Arial"/>
-              </a:rPr>
-              <a:t>The honest mistake: we were not determined enough; we should have exited in full and taken the ~20% hit at once.</a:t>
-            </a:r>
-          </a:p>
-        </p:txBody>
-      </p:sp>
-      <p:sp>
-        <p:nvSpPr>
-          <p:cNvPr id="10" name="TextBox 9"/>
+              <a:t>Company &amp; position</a:t>
+            </a:r>
+          </a:p>
+        </p:txBody>
+      </p:sp>
+      <p:sp>
+        <p:nvSpPr>
+          <p:cNvPr id="11" name="Rectangle 10"/>
+          <p:cNvSpPr/>
+          <p:nvPr/>
+        </p:nvSpPr>
+        <p:spPr>
+          <a:xfrm>
+            <a:off x="1938575" y="2340864"/>
+            <a:ext cx="1389922" cy="536448"/>
+          </a:xfrm>
+          <a:prstGeom prst="rect">
+            <a:avLst/>
+          </a:prstGeom>
+          <a:solidFill>
+            <a:srgbClr val="314359"/>
+          </a:solidFill>
+          <a:ln>
+            <a:noFill/>
+          </a:ln>
+          <a:effectLst/>
+        </p:spPr>
+        <p:style>
+          <a:lnRef idx="1">
+            <a:schemeClr val="accent1"/>
+          </a:lnRef>
+          <a:fillRef idx="3">
+            <a:schemeClr val="accent1"/>
+          </a:fillRef>
+          <a:effectRef idx="2">
+            <a:schemeClr val="accent1"/>
+          </a:effectRef>
+          <a:fontRef idx="minor">
+            <a:schemeClr val="lt1"/>
+          </a:fontRef>
+        </p:style>
+        <p:txBody>
+          <a:bodyPr rtlCol="0" anchor="ctr"/>
+          <a:lstStyle/>
+          <a:p>
+            <a:pPr algn="ctr"/>
+          </a:p>
+        </p:txBody>
+      </p:sp>
+      <p:sp>
+        <p:nvSpPr>
+          <p:cNvPr id="12" name="TextBox 11"/>
           <p:cNvSpPr txBox="1"/>
           <p:nvPr/>
         </p:nvSpPr>
         <p:spPr>
           <a:xfrm>
-            <a:off x="5120768" y="2340864"/>
-            <a:ext cx="4279499" cy="4194048"/>
+            <a:off x="2011729" y="2340864"/>
+            <a:ext cx="1258245" cy="536448"/>
           </a:xfrm>
           <a:prstGeom prst="rect">
             <a:avLst/>
@@ -3503,117 +3515,385 @@
           <a:noFill/>
         </p:spPr>
         <p:txBody>
-          <a:bodyPr wrap="square" anchor="t" lIns="0" rIns="0" tIns="0" bIns="0">
+          <a:bodyPr wrap="square" anchor="ctr" lIns="0" rIns="0" tIns="0" bIns="0">
             <a:spAutoFit/>
           </a:bodyPr>
           <a:lstStyle/>
           <a:p>
             <a:pPr algn="l">
               <a:lnSpc>
-                <a:spcPct val="110000"/>
+                <a:spcPct val="104000"/>
               </a:lnSpc>
               <a:spcAft>
-                <a:spcPts val="800"/>
+                <a:spcPts val="0"/>
               </a:spcAft>
             </a:pPr>
             <a:r>
-              <a:rPr sz="1000" b="1" i="0">
+              <a:rPr sz="720" b="1" i="0">
                 <a:solidFill>
-                  <a:srgbClr val="314359"/>
+                  <a:srgbClr val="FFFFFF"/>
                 </a:solidFill>
                 <a:latin typeface="Arial"/>
               </a:rPr>
-              <a:t>ROBIT — AGREEMENT BEFORE CAPITAL</a:t>
-            </a:r>
-          </a:p>
+              <a:t>Thesis &amp; engagement</a:t>
+            </a:r>
+          </a:p>
+        </p:txBody>
+      </p:sp>
+      <p:sp>
+        <p:nvSpPr>
+          <p:cNvPr id="13" name="Rectangle 12"/>
+          <p:cNvSpPr/>
+          <p:nvPr/>
+        </p:nvSpPr>
+        <p:spPr>
+          <a:xfrm>
+            <a:off x="3328498" y="2340864"/>
+            <a:ext cx="1463076" cy="536448"/>
+          </a:xfrm>
+          <a:prstGeom prst="rect">
+            <a:avLst/>
+          </a:prstGeom>
+          <a:solidFill>
+            <a:srgbClr val="314359"/>
+          </a:solidFill>
+          <a:ln>
+            <a:noFill/>
+          </a:ln>
+          <a:effectLst/>
+        </p:spPr>
+        <p:style>
+          <a:lnRef idx="1">
+            <a:schemeClr val="accent1"/>
+          </a:lnRef>
+          <a:fillRef idx="3">
+            <a:schemeClr val="accent1"/>
+          </a:fillRef>
+          <a:effectRef idx="2">
+            <a:schemeClr val="accent1"/>
+          </a:effectRef>
+          <a:fontRef idx="minor">
+            <a:schemeClr val="lt1"/>
+          </a:fontRef>
+        </p:style>
+        <p:txBody>
+          <a:bodyPr rtlCol="0" anchor="ctr"/>
+          <a:lstStyle/>
+          <a:p>
+            <a:pPr algn="ctr"/>
+          </a:p>
+        </p:txBody>
+      </p:sp>
+      <p:sp>
+        <p:nvSpPr>
+          <p:cNvPr id="14" name="TextBox 13"/>
+          <p:cNvSpPr txBox="1"/>
+          <p:nvPr/>
+        </p:nvSpPr>
+        <p:spPr>
+          <a:xfrm>
+            <a:off x="3401652" y="2340864"/>
+            <a:ext cx="1331399" cy="536448"/>
+          </a:xfrm>
+          <a:prstGeom prst="rect">
+            <a:avLst/>
+          </a:prstGeom>
+          <a:noFill/>
+        </p:spPr>
+        <p:txBody>
+          <a:bodyPr wrap="square" anchor="ctr" lIns="0" rIns="0" tIns="0" bIns="0">
+            <a:spAutoFit/>
+          </a:bodyPr>
+          <a:lstStyle/>
           <a:p>
             <a:pPr algn="l">
               <a:lnSpc>
-                <a:spcPct val="114000"/>
+                <a:spcPct val="104000"/>
               </a:lnSpc>
               <a:spcAft>
-                <a:spcPts val="800"/>
+                <a:spcPts val="0"/>
               </a:spcAft>
             </a:pPr>
             <a:r>
-              <a:rPr sz="1000" b="0" i="0">
+              <a:rPr sz="720" b="1" i="0">
                 <a:solidFill>
-                  <a:srgbClr val="0E1620"/>
+                  <a:srgbClr val="FFFFFF"/>
                 </a:solidFill>
                 <a:latin typeface="Arial"/>
               </a:rPr>
-              <a:t>Built a position (from May 2015): invested in stages in a niche drilling-consumables franchise trading below intrinsic value.</a:t>
-            </a:r>
-          </a:p>
+              <a:t>The risk trigger</a:t>
+            </a:r>
+          </a:p>
+        </p:txBody>
+      </p:sp>
+      <p:sp>
+        <p:nvSpPr>
+          <p:cNvPr id="15" name="Rectangle 14"/>
+          <p:cNvSpPr/>
+          <p:nvPr/>
+        </p:nvSpPr>
+        <p:spPr>
+          <a:xfrm>
+            <a:off x="4791575" y="2340864"/>
+            <a:ext cx="1719115" cy="536448"/>
+          </a:xfrm>
+          <a:prstGeom prst="rect">
+            <a:avLst/>
+          </a:prstGeom>
+          <a:solidFill>
+            <a:srgbClr val="314359"/>
+          </a:solidFill>
+          <a:ln>
+            <a:noFill/>
+          </a:ln>
+          <a:effectLst/>
+        </p:spPr>
+        <p:style>
+          <a:lnRef idx="1">
+            <a:schemeClr val="accent1"/>
+          </a:lnRef>
+          <a:fillRef idx="3">
+            <a:schemeClr val="accent1"/>
+          </a:fillRef>
+          <a:effectRef idx="2">
+            <a:schemeClr val="accent1"/>
+          </a:effectRef>
+          <a:fontRef idx="minor">
+            <a:schemeClr val="lt1"/>
+          </a:fontRef>
+        </p:style>
+        <p:txBody>
+          <a:bodyPr rtlCol="0" anchor="ctr"/>
+          <a:lstStyle/>
+          <a:p>
+            <a:pPr algn="ctr"/>
+          </a:p>
+        </p:txBody>
+      </p:sp>
+      <p:sp>
+        <p:nvSpPr>
+          <p:cNvPr id="16" name="TextBox 15"/>
+          <p:cNvSpPr txBox="1"/>
+          <p:nvPr/>
+        </p:nvSpPr>
+        <p:spPr>
+          <a:xfrm>
+            <a:off x="4864728" y="2340864"/>
+            <a:ext cx="1587438" cy="536448"/>
+          </a:xfrm>
+          <a:prstGeom prst="rect">
+            <a:avLst/>
+          </a:prstGeom>
+          <a:noFill/>
+        </p:spPr>
+        <p:txBody>
+          <a:bodyPr wrap="square" anchor="ctr" lIns="0" rIns="0" tIns="0" bIns="0">
+            <a:spAutoFit/>
+          </a:bodyPr>
+          <a:lstStyle/>
           <a:p>
             <a:pPr algn="l">
               <a:lnSpc>
-                <a:spcPct val="114000"/>
+                <a:spcPct val="104000"/>
               </a:lnSpc>
               <a:spcAft>
-                <a:spcPts val="800"/>
+                <a:spcPts val="0"/>
               </a:spcAft>
             </a:pPr>
             <a:r>
-              <a:rPr sz="1000" b="0" i="0">
+              <a:rPr sz="720" b="1" i="0">
                 <a:solidFill>
-                  <a:srgbClr val="0E1620"/>
+                  <a:srgbClr val="FFFFFF"/>
                 </a:solidFill>
                 <a:latin typeface="Arial"/>
               </a:rPr>
-              <a:t>Sought engagement (from 2019): pursued a board seat to fix the cost base and capital allocation — a board-level plan.</a:t>
-            </a:r>
-          </a:p>
+              <a:t>The disciplined action</a:t>
+            </a:r>
+          </a:p>
+        </p:txBody>
+      </p:sp>
+      <p:sp>
+        <p:nvSpPr>
+          <p:cNvPr id="17" name="Rectangle 16"/>
+          <p:cNvSpPr/>
+          <p:nvPr/>
+        </p:nvSpPr>
+        <p:spPr>
+          <a:xfrm>
+            <a:off x="6510690" y="2340864"/>
+            <a:ext cx="1243615" cy="536448"/>
+          </a:xfrm>
+          <a:prstGeom prst="rect">
+            <a:avLst/>
+          </a:prstGeom>
+          <a:solidFill>
+            <a:srgbClr val="314359"/>
+          </a:solidFill>
+          <a:ln>
+            <a:noFill/>
+          </a:ln>
+          <a:effectLst/>
+        </p:spPr>
+        <p:style>
+          <a:lnRef idx="1">
+            <a:schemeClr val="accent1"/>
+          </a:lnRef>
+          <a:fillRef idx="3">
+            <a:schemeClr val="accent1"/>
+          </a:fillRef>
+          <a:effectRef idx="2">
+            <a:schemeClr val="accent1"/>
+          </a:effectRef>
+          <a:fontRef idx="minor">
+            <a:schemeClr val="lt1"/>
+          </a:fontRef>
+        </p:style>
+        <p:txBody>
+          <a:bodyPr rtlCol="0" anchor="ctr"/>
+          <a:lstStyle/>
+          <a:p>
+            <a:pPr algn="ctr"/>
+          </a:p>
+        </p:txBody>
+      </p:sp>
+      <p:sp>
+        <p:nvSpPr>
+          <p:cNvPr id="18" name="TextBox 17"/>
+          <p:cNvSpPr txBox="1"/>
+          <p:nvPr/>
+        </p:nvSpPr>
+        <p:spPr>
+          <a:xfrm>
+            <a:off x="6583843" y="2340864"/>
+            <a:ext cx="1111938" cy="536448"/>
+          </a:xfrm>
+          <a:prstGeom prst="rect">
+            <a:avLst/>
+          </a:prstGeom>
+          <a:noFill/>
+        </p:spPr>
+        <p:txBody>
+          <a:bodyPr wrap="square" anchor="ctr" lIns="0" rIns="0" tIns="0" bIns="0">
+            <a:spAutoFit/>
+          </a:bodyPr>
+          <a:lstStyle/>
           <a:p>
             <a:pPr algn="l">
               <a:lnSpc>
-                <a:spcPct val="114000"/>
+                <a:spcPct val="104000"/>
               </a:lnSpc>
               <a:spcAft>
-                <a:spcPts val="800"/>
+                <a:spcPts val="0"/>
               </a:spcAft>
             </a:pPr>
             <a:r>
-              <a:rPr sz="1000" b="0" i="0">
+              <a:rPr sz="720" b="1" i="0">
                 <a:solidFill>
-                  <a:srgbClr val="0E1620"/>
+                  <a:srgbClr val="FFFFFF"/>
                 </a:solidFill>
                 <a:latin typeface="Arial"/>
               </a:rPr>
-              <a:t>The breaking point: we could not secure board alignment.</a:t>
-            </a:r>
-          </a:p>
+              <a:t>Outcome</a:t>
+            </a:r>
+          </a:p>
+        </p:txBody>
+      </p:sp>
+      <p:sp>
+        <p:nvSpPr>
+          <p:cNvPr id="19" name="Rectangle 18"/>
+          <p:cNvSpPr/>
+          <p:nvPr/>
+        </p:nvSpPr>
+        <p:spPr>
+          <a:xfrm>
+            <a:off x="7754305" y="2340864"/>
+            <a:ext cx="1536230" cy="536448"/>
+          </a:xfrm>
+          <a:prstGeom prst="rect">
+            <a:avLst/>
+          </a:prstGeom>
+          <a:solidFill>
+            <a:srgbClr val="314359"/>
+          </a:solidFill>
+          <a:ln>
+            <a:noFill/>
+          </a:ln>
+          <a:effectLst/>
+        </p:spPr>
+        <p:style>
+          <a:lnRef idx="1">
+            <a:schemeClr val="accent1"/>
+          </a:lnRef>
+          <a:fillRef idx="3">
+            <a:schemeClr val="accent1"/>
+          </a:fillRef>
+          <a:effectRef idx="2">
+            <a:schemeClr val="accent1"/>
+          </a:effectRef>
+          <a:fontRef idx="minor">
+            <a:schemeClr val="lt1"/>
+          </a:fontRef>
+        </p:style>
+        <p:txBody>
+          <a:bodyPr rtlCol="0" anchor="ctr"/>
+          <a:lstStyle/>
+          <a:p>
+            <a:pPr algn="ctr"/>
+          </a:p>
+        </p:txBody>
+      </p:sp>
+      <p:sp>
+        <p:nvSpPr>
+          <p:cNvPr id="20" name="TextBox 19"/>
+          <p:cNvSpPr txBox="1"/>
+          <p:nvPr/>
+        </p:nvSpPr>
+        <p:spPr>
+          <a:xfrm>
+            <a:off x="7827459" y="2340864"/>
+            <a:ext cx="1404553" cy="536448"/>
+          </a:xfrm>
+          <a:prstGeom prst="rect">
+            <a:avLst/>
+          </a:prstGeom>
+          <a:noFill/>
+        </p:spPr>
+        <p:txBody>
+          <a:bodyPr wrap="square" anchor="ctr" lIns="0" rIns="0" tIns="0" bIns="0">
+            <a:spAutoFit/>
+          </a:bodyPr>
+          <a:lstStyle/>
           <a:p>
             <a:pPr algn="l">
               <a:lnSpc>
-                <a:spcPct val="114000"/>
+                <a:spcPct val="104000"/>
               </a:lnSpc>
               <a:spcAft>
-                <a:spcPts val="800"/>
+                <a:spcPts val="0"/>
               </a:spcAft>
             </a:pPr>
             <a:r>
-              <a:rPr sz="1000" b="0" i="0">
+              <a:rPr sz="720" b="1" i="0">
                 <a:solidFill>
-                  <a:srgbClr val="0E1620"/>
+                  <a:srgbClr val="FFFFFF"/>
                 </a:solidFill>
                 <a:latin typeface="Arial"/>
               </a:rPr>
-              <a:t>Walked away: unwound rather than stay without influence — exiting at ~14% IRR (&gt;2× the index). The shares have since roughly halved, so the discipline avoided the loss.</a:t>
-            </a:r>
-          </a:p>
-        </p:txBody>
-      </p:sp>
-      <p:sp>
-        <p:nvSpPr>
-          <p:cNvPr id="11" name="Rectangle 10"/>
+              <a:t>What it taught the system</a:t>
+            </a:r>
+          </a:p>
+        </p:txBody>
+      </p:sp>
+      <p:sp>
+        <p:nvSpPr>
+          <p:cNvPr id="21" name="Rectangle 20"/>
           <p:cNvSpPr/>
           <p:nvPr/>
         </p:nvSpPr>
         <p:spPr>
           <a:xfrm>
-            <a:off x="438922" y="5149900"/>
-            <a:ext cx="8895505" cy="897331"/>
+            <a:off x="438922" y="2877312"/>
+            <a:ext cx="1499652" cy="1511808"/>
           </a:xfrm>
           <a:prstGeom prst="rect">
             <a:avLst/>
@@ -3650,14 +3930,14 @@
       </p:sp>
       <p:sp>
         <p:nvSpPr>
-          <p:cNvPr id="12" name="Rectangle 11"/>
+          <p:cNvPr id="22" name="Rectangle 21"/>
           <p:cNvSpPr/>
           <p:nvPr/>
         </p:nvSpPr>
         <p:spPr>
           <a:xfrm>
-            <a:off x="438922" y="5149900"/>
-            <a:ext cx="51207" cy="897331"/>
+            <a:off x="438922" y="2877312"/>
+            <a:ext cx="43892" cy="1511808"/>
           </a:xfrm>
           <a:prstGeom prst="rect">
             <a:avLst/>
@@ -3694,14 +3974,14 @@
       </p:sp>
       <p:sp>
         <p:nvSpPr>
-          <p:cNvPr id="13" name="TextBox 12"/>
+          <p:cNvPr id="23" name="TextBox 22"/>
           <p:cNvSpPr txBox="1"/>
           <p:nvPr/>
         </p:nvSpPr>
         <p:spPr>
           <a:xfrm>
-            <a:off x="621807" y="5227929"/>
-            <a:ext cx="8485844" cy="292608"/>
+            <a:off x="534022" y="2974848"/>
+            <a:ext cx="1338714" cy="1336243"/>
           </a:xfrm>
           <a:prstGeom prst="rect">
             <a:avLst/>
@@ -3716,76 +3996,508 @@
           <a:p>
             <a:pPr algn="l">
               <a:lnSpc>
-                <a:spcPct val="110000"/>
-              </a:lnSpc>
-              <a:spcAft>
-                <a:spcPts val="400"/>
-              </a:spcAft>
-            </a:pPr>
-            <a:r>
-              <a:rPr sz="960" b="1" i="0">
-                <a:solidFill>
-                  <a:srgbClr val="152130"/>
-                </a:solidFill>
-                <a:latin typeface="Arial"/>
-              </a:rPr>
-              <a:t>THE DISCIPLINE IT BUILT</a:t>
-            </a:r>
-          </a:p>
-        </p:txBody>
-      </p:sp>
-      <p:sp>
-        <p:nvSpPr>
-          <p:cNvPr id="14" name="TextBox 13"/>
-          <p:cNvSpPr txBox="1"/>
-          <p:nvPr/>
-        </p:nvSpPr>
-        <p:spPr>
-          <a:xfrm>
-            <a:off x="621807" y="5520537"/>
-            <a:ext cx="8558998" cy="487680"/>
-          </a:xfrm>
-          <a:prstGeom prst="rect">
-            <a:avLst/>
-          </a:prstGeom>
-          <a:noFill/>
-        </p:spPr>
-        <p:txBody>
-          <a:bodyPr wrap="square" anchor="t" lIns="0" rIns="0" tIns="0" bIns="0">
-            <a:spAutoFit/>
-          </a:bodyPr>
-          <a:lstStyle/>
-          <a:p>
-            <a:pPr algn="l">
-              <a:lnSpc>
-                <a:spcPct val="114000"/>
+                <a:spcPct val="112000"/>
               </a:lnSpc>
               <a:spcAft>
                 <a:spcPts val="0"/>
               </a:spcAft>
             </a:pPr>
             <a:r>
-              <a:rPr sz="880" b="0" i="0">
+              <a:rPr sz="680" b="1" i="0">
+                <a:solidFill>
+                  <a:srgbClr val="314359"/>
+                </a:solidFill>
+                <a:latin typeface="Arial"/>
+              </a:rPr>
+              <a:t>DistIT — Nasdaq Stockholm. Bought from 2015; built it with a new management team and board.</a:t>
+            </a:r>
+          </a:p>
+        </p:txBody>
+      </p:sp>
+      <p:sp>
+        <p:nvSpPr>
+          <p:cNvPr id="24" name="Rectangle 23"/>
+          <p:cNvSpPr/>
+          <p:nvPr/>
+        </p:nvSpPr>
+        <p:spPr>
+          <a:xfrm>
+            <a:off x="1938575" y="2877312"/>
+            <a:ext cx="1389922" cy="1511808"/>
+          </a:xfrm>
+          <a:prstGeom prst="rect">
+            <a:avLst/>
+          </a:prstGeom>
+          <a:solidFill>
+            <a:srgbClr val="F6F7F9"/>
+          </a:solidFill>
+          <a:ln>
+            <a:noFill/>
+          </a:ln>
+          <a:effectLst/>
+        </p:spPr>
+        <p:style>
+          <a:lnRef idx="1">
+            <a:schemeClr val="accent1"/>
+          </a:lnRef>
+          <a:fillRef idx="3">
+            <a:schemeClr val="accent1"/>
+          </a:fillRef>
+          <a:effectRef idx="2">
+            <a:schemeClr val="accent1"/>
+          </a:effectRef>
+          <a:fontRef idx="minor">
+            <a:schemeClr val="lt1"/>
+          </a:fontRef>
+        </p:style>
+        <p:txBody>
+          <a:bodyPr rtlCol="0" anchor="ctr"/>
+          <a:lstStyle/>
+          <a:p>
+            <a:pPr algn="ctr"/>
+          </a:p>
+        </p:txBody>
+      </p:sp>
+      <p:sp>
+        <p:nvSpPr>
+          <p:cNvPr id="25" name="TextBox 24"/>
+          <p:cNvSpPr txBox="1"/>
+          <p:nvPr/>
+        </p:nvSpPr>
+        <p:spPr>
+          <a:xfrm>
+            <a:off x="2033675" y="2974848"/>
+            <a:ext cx="1228984" cy="1336243"/>
+          </a:xfrm>
+          <a:prstGeom prst="rect">
+            <a:avLst/>
+          </a:prstGeom>
+          <a:noFill/>
+        </p:spPr>
+        <p:txBody>
+          <a:bodyPr wrap="square" anchor="t" lIns="0" rIns="0" tIns="0" bIns="0">
+            <a:spAutoFit/>
+          </a:bodyPr>
+          <a:lstStyle/>
+          <a:p>
+            <a:pPr algn="l">
+              <a:lnSpc>
+                <a:spcPct val="112000"/>
+              </a:lnSpc>
+              <a:spcAft>
+                <a:spcPts val="0"/>
+              </a:spcAft>
+            </a:pPr>
+            <a:r>
+              <a:rPr sz="680" b="0" i="0">
                 <a:solidFill>
                   <a:srgbClr val="0E1620"/>
                 </a:solidFill>
                 <a:latin typeface="Arial"/>
               </a:rPr>
-              <a:t>Two routes, one rule — act on the facts, not the share price. Robit set the precondition (no board alignment, no capital); DistIT set the exit (when the thesis breaks, sell completely). Selling DistIT too gradually is the origin of our determined-seller framework.</a:t>
-            </a:r>
-          </a:p>
-        </p:txBody>
-      </p:sp>
-      <p:sp>
-        <p:nvSpPr>
-          <p:cNvPr id="15" name="Rectangle 14"/>
+              <a:t>Active owner with a board seat — compound a Nordic distribution platform.</a:t>
+            </a:r>
+          </a:p>
+        </p:txBody>
+      </p:sp>
+      <p:sp>
+        <p:nvSpPr>
+          <p:cNvPr id="26" name="Rectangle 25"/>
           <p:cNvSpPr/>
           <p:nvPr/>
         </p:nvSpPr>
         <p:spPr>
           <a:xfrm>
-            <a:off x="438922" y="6300825"/>
-            <a:ext cx="8895505" cy="585216"/>
+            <a:off x="3328498" y="2877312"/>
+            <a:ext cx="1463076" cy="1511808"/>
+          </a:xfrm>
+          <a:prstGeom prst="rect">
+            <a:avLst/>
+          </a:prstGeom>
+          <a:solidFill>
+            <a:srgbClr val="F6F7F9"/>
+          </a:solidFill>
+          <a:ln>
+            <a:noFill/>
+          </a:ln>
+          <a:effectLst/>
+        </p:spPr>
+        <p:style>
+          <a:lnRef idx="1">
+            <a:schemeClr val="accent1"/>
+          </a:lnRef>
+          <a:fillRef idx="3">
+            <a:schemeClr val="accent1"/>
+          </a:fillRef>
+          <a:effectRef idx="2">
+            <a:schemeClr val="accent1"/>
+          </a:effectRef>
+          <a:fontRef idx="minor">
+            <a:schemeClr val="lt1"/>
+          </a:fontRef>
+        </p:style>
+        <p:txBody>
+          <a:bodyPr rtlCol="0" anchor="ctr"/>
+          <a:lstStyle/>
+          <a:p>
+            <a:pPr algn="ctr"/>
+          </a:p>
+        </p:txBody>
+      </p:sp>
+      <p:sp>
+        <p:nvSpPr>
+          <p:cNvPr id="27" name="TextBox 26"/>
+          <p:cNvSpPr txBox="1"/>
+          <p:nvPr/>
+        </p:nvSpPr>
+        <p:spPr>
+          <a:xfrm>
+            <a:off x="3423598" y="2974848"/>
+            <a:ext cx="1302138" cy="1336243"/>
+          </a:xfrm>
+          <a:prstGeom prst="rect">
+            <a:avLst/>
+          </a:prstGeom>
+          <a:noFill/>
+        </p:spPr>
+        <p:txBody>
+          <a:bodyPr wrap="square" anchor="t" lIns="0" rIns="0" tIns="0" bIns="0">
+            <a:spAutoFit/>
+          </a:bodyPr>
+          <a:lstStyle/>
+          <a:p>
+            <a:pPr algn="l">
+              <a:lnSpc>
+                <a:spcPct val="112000"/>
+              </a:lnSpc>
+              <a:spcAft>
+                <a:spcPts val="0"/>
+              </a:spcAft>
+            </a:pPr>
+            <a:r>
+              <a:rPr sz="680" b="0" i="0">
+                <a:solidFill>
+                  <a:srgbClr val="0E1620"/>
+                </a:solidFill>
+                <a:latin typeface="Arial"/>
+              </a:rPr>
+              <a:t>2021: the EFUEL acquisition we had warned against went ahead; we judged the company overvalued — thesis broken.</a:t>
+            </a:r>
+          </a:p>
+        </p:txBody>
+      </p:sp>
+      <p:sp>
+        <p:nvSpPr>
+          <p:cNvPr id="28" name="Rectangle 27"/>
+          <p:cNvSpPr/>
+          <p:nvPr/>
+        </p:nvSpPr>
+        <p:spPr>
+          <a:xfrm>
+            <a:off x="4791575" y="2877312"/>
+            <a:ext cx="1719115" cy="1511808"/>
+          </a:xfrm>
+          <a:prstGeom prst="rect">
+            <a:avLst/>
+          </a:prstGeom>
+          <a:solidFill>
+            <a:srgbClr val="F6F7F9"/>
+          </a:solidFill>
+          <a:ln>
+            <a:noFill/>
+          </a:ln>
+          <a:effectLst/>
+        </p:spPr>
+        <p:style>
+          <a:lnRef idx="1">
+            <a:schemeClr val="accent1"/>
+          </a:lnRef>
+          <a:fillRef idx="3">
+            <a:schemeClr val="accent1"/>
+          </a:fillRef>
+          <a:effectRef idx="2">
+            <a:schemeClr val="accent1"/>
+          </a:effectRef>
+          <a:fontRef idx="minor">
+            <a:schemeClr val="lt1"/>
+          </a:fontRef>
+        </p:style>
+        <p:txBody>
+          <a:bodyPr rtlCol="0" anchor="ctr"/>
+          <a:lstStyle/>
+          <a:p>
+            <a:pPr algn="ctr"/>
+          </a:p>
+        </p:txBody>
+      </p:sp>
+      <p:sp>
+        <p:nvSpPr>
+          <p:cNvPr id="29" name="TextBox 28"/>
+          <p:cNvSpPr txBox="1"/>
+          <p:nvPr/>
+        </p:nvSpPr>
+        <p:spPr>
+          <a:xfrm>
+            <a:off x="4886675" y="2974848"/>
+            <a:ext cx="1558176" cy="1336243"/>
+          </a:xfrm>
+          <a:prstGeom prst="rect">
+            <a:avLst/>
+          </a:prstGeom>
+          <a:noFill/>
+        </p:spPr>
+        <p:txBody>
+          <a:bodyPr wrap="square" anchor="t" lIns="0" rIns="0" tIns="0" bIns="0">
+            <a:spAutoFit/>
+          </a:bodyPr>
+          <a:lstStyle/>
+          <a:p>
+            <a:pPr algn="l">
+              <a:lnSpc>
+                <a:spcPct val="112000"/>
+              </a:lnSpc>
+              <a:spcAft>
+                <a:spcPts val="0"/>
+              </a:spcAft>
+            </a:pPr>
+            <a:r>
+              <a:rPr sz="680" b="0" i="0">
+                <a:solidFill>
+                  <a:srgbClr val="0E1620"/>
+                </a:solidFill>
+                <a:latin typeface="Arial"/>
+              </a:rPr>
+              <a:t>From the board, forced the price down ~40% (SEK 300m → 180m + earn-out, which never paid). Sold across two blocks — into a rising price, not a falling one.</a:t>
+            </a:r>
+          </a:p>
+        </p:txBody>
+      </p:sp>
+      <p:sp>
+        <p:nvSpPr>
+          <p:cNvPr id="30" name="Rectangle 29"/>
+          <p:cNvSpPr/>
+          <p:nvPr/>
+        </p:nvSpPr>
+        <p:spPr>
+          <a:xfrm>
+            <a:off x="6510690" y="2877312"/>
+            <a:ext cx="1243615" cy="1511808"/>
+          </a:xfrm>
+          <a:prstGeom prst="rect">
+            <a:avLst/>
+          </a:prstGeom>
+          <a:solidFill>
+            <a:srgbClr val="F6F7F9"/>
+          </a:solidFill>
+          <a:ln>
+            <a:noFill/>
+          </a:ln>
+          <a:effectLst/>
+        </p:spPr>
+        <p:style>
+          <a:lnRef idx="1">
+            <a:schemeClr val="accent1"/>
+          </a:lnRef>
+          <a:fillRef idx="3">
+            <a:schemeClr val="accent1"/>
+          </a:fillRef>
+          <a:effectRef idx="2">
+            <a:schemeClr val="accent1"/>
+          </a:effectRef>
+          <a:fontRef idx="minor">
+            <a:schemeClr val="lt1"/>
+          </a:fontRef>
+        </p:style>
+        <p:txBody>
+          <a:bodyPr rtlCol="0" anchor="ctr"/>
+          <a:lstStyle/>
+          <a:p>
+            <a:pPr algn="ctr"/>
+          </a:p>
+        </p:txBody>
+      </p:sp>
+      <p:sp>
+        <p:nvSpPr>
+          <p:cNvPr id="31" name="TextBox 30"/>
+          <p:cNvSpPr txBox="1"/>
+          <p:nvPr/>
+        </p:nvSpPr>
+        <p:spPr>
+          <a:xfrm>
+            <a:off x="6605790" y="2974848"/>
+            <a:ext cx="1082676" cy="1336243"/>
+          </a:xfrm>
+          <a:prstGeom prst="rect">
+            <a:avLst/>
+          </a:prstGeom>
+          <a:noFill/>
+        </p:spPr>
+        <p:txBody>
+          <a:bodyPr wrap="square" anchor="t" lIns="0" rIns="0" tIns="0" bIns="0">
+            <a:spAutoFit/>
+          </a:bodyPr>
+          <a:lstStyle/>
+          <a:p>
+            <a:pPr algn="l">
+              <a:lnSpc>
+                <a:spcPct val="112000"/>
+              </a:lnSpc>
+              <a:spcAft>
+                <a:spcPts val="0"/>
+              </a:spcAft>
+            </a:pPr>
+            <a:r>
+              <a:rPr sz="680" b="0" i="0">
+                <a:solidFill>
+                  <a:srgbClr val="0E1620"/>
+                </a:solidFill>
+                <a:latin typeface="Arial"/>
+              </a:rPr>
+              <a:t>Profitable overall — but we sold too gradually instead of exiting in full.</a:t>
+            </a:r>
+          </a:p>
+        </p:txBody>
+      </p:sp>
+      <p:sp>
+        <p:nvSpPr>
+          <p:cNvPr id="32" name="Rectangle 31"/>
+          <p:cNvSpPr/>
+          <p:nvPr/>
+        </p:nvSpPr>
+        <p:spPr>
+          <a:xfrm>
+            <a:off x="7754305" y="2877312"/>
+            <a:ext cx="1536230" cy="1511808"/>
+          </a:xfrm>
+          <a:prstGeom prst="rect">
+            <a:avLst/>
+          </a:prstGeom>
+          <a:solidFill>
+            <a:srgbClr val="F6F7F9"/>
+          </a:solidFill>
+          <a:ln>
+            <a:noFill/>
+          </a:ln>
+          <a:effectLst/>
+        </p:spPr>
+        <p:style>
+          <a:lnRef idx="1">
+            <a:schemeClr val="accent1"/>
+          </a:lnRef>
+          <a:fillRef idx="3">
+            <a:schemeClr val="accent1"/>
+          </a:fillRef>
+          <a:effectRef idx="2">
+            <a:schemeClr val="accent1"/>
+          </a:effectRef>
+          <a:fontRef idx="minor">
+            <a:schemeClr val="lt1"/>
+          </a:fontRef>
+        </p:style>
+        <p:txBody>
+          <a:bodyPr rtlCol="0" anchor="ctr"/>
+          <a:lstStyle/>
+          <a:p>
+            <a:pPr algn="ctr"/>
+          </a:p>
+        </p:txBody>
+      </p:sp>
+      <p:sp>
+        <p:nvSpPr>
+          <p:cNvPr id="33" name="TextBox 32"/>
+          <p:cNvSpPr txBox="1"/>
+          <p:nvPr/>
+        </p:nvSpPr>
+        <p:spPr>
+          <a:xfrm>
+            <a:off x="7849405" y="2974848"/>
+            <a:ext cx="1375292" cy="1336243"/>
+          </a:xfrm>
+          <a:prstGeom prst="rect">
+            <a:avLst/>
+          </a:prstGeom>
+          <a:noFill/>
+        </p:spPr>
+        <p:txBody>
+          <a:bodyPr wrap="square" anchor="t" lIns="0" rIns="0" tIns="0" bIns="0">
+            <a:spAutoFit/>
+          </a:bodyPr>
+          <a:lstStyle/>
+          <a:p>
+            <a:pPr algn="l">
+              <a:lnSpc>
+                <a:spcPct val="112000"/>
+              </a:lnSpc>
+              <a:spcAft>
+                <a:spcPts val="0"/>
+              </a:spcAft>
+            </a:pPr>
+            <a:r>
+              <a:rPr sz="680" b="0" i="0">
+                <a:solidFill>
+                  <a:srgbClr val="0E1620"/>
+                </a:solidFill>
+                <a:latin typeface="Arial"/>
+              </a:rPr>
+              <a:t>Origin of the determined-seller framework: when the thesis breaks, exit completely — on the facts, not the price.</a:t>
+            </a:r>
+          </a:p>
+        </p:txBody>
+      </p:sp>
+      <p:sp>
+        <p:nvSpPr>
+          <p:cNvPr id="34" name="Rectangle 33"/>
+          <p:cNvSpPr/>
+          <p:nvPr/>
+        </p:nvSpPr>
+        <p:spPr>
+          <a:xfrm>
+            <a:off x="438922" y="4389120"/>
+            <a:ext cx="1499652" cy="1511808"/>
+          </a:xfrm>
+          <a:prstGeom prst="rect">
+            <a:avLst/>
+          </a:prstGeom>
+          <a:solidFill>
+            <a:srgbClr val="FFFFFF"/>
+          </a:solidFill>
+          <a:ln>
+            <a:noFill/>
+          </a:ln>
+          <a:effectLst/>
+        </p:spPr>
+        <p:style>
+          <a:lnRef idx="1">
+            <a:schemeClr val="accent1"/>
+          </a:lnRef>
+          <a:fillRef idx="3">
+            <a:schemeClr val="accent1"/>
+          </a:fillRef>
+          <a:effectRef idx="2">
+            <a:schemeClr val="accent1"/>
+          </a:effectRef>
+          <a:fontRef idx="minor">
+            <a:schemeClr val="lt1"/>
+          </a:fontRef>
+        </p:style>
+        <p:txBody>
+          <a:bodyPr rtlCol="0" anchor="ctr"/>
+          <a:lstStyle/>
+          <a:p>
+            <a:pPr algn="ctr"/>
+          </a:p>
+        </p:txBody>
+      </p:sp>
+      <p:sp>
+        <p:nvSpPr>
+          <p:cNvPr id="35" name="Rectangle 34"/>
+          <p:cNvSpPr/>
+          <p:nvPr/>
+        </p:nvSpPr>
+        <p:spPr>
+          <a:xfrm>
+            <a:off x="438922" y="4389120"/>
+            <a:ext cx="43892" cy="1511808"/>
           </a:xfrm>
           <a:prstGeom prst="rect">
             <a:avLst/>
@@ -3822,14 +4534,14 @@
       </p:sp>
       <p:sp>
         <p:nvSpPr>
-          <p:cNvPr id="16" name="TextBox 15"/>
+          <p:cNvPr id="36" name="TextBox 35"/>
           <p:cNvSpPr txBox="1"/>
           <p:nvPr/>
         </p:nvSpPr>
         <p:spPr>
           <a:xfrm>
-            <a:off x="585230" y="6300825"/>
-            <a:ext cx="8632151" cy="585216"/>
+            <a:off x="534022" y="4486656"/>
+            <a:ext cx="1338714" cy="1336243"/>
           </a:xfrm>
           <a:prstGeom prst="rect">
             <a:avLst/>
@@ -3837,7 +4549,479 @@
           <a:noFill/>
         </p:spPr>
         <p:txBody>
-          <a:bodyPr wrap="square" anchor="ctr" lIns="0" rIns="0" tIns="0" bIns="0">
+          <a:bodyPr wrap="square" anchor="t" lIns="0" rIns="0" tIns="0" bIns="0">
+            <a:spAutoFit/>
+          </a:bodyPr>
+          <a:lstStyle/>
+          <a:p>
+            <a:pPr algn="l">
+              <a:lnSpc>
+                <a:spcPct val="112000"/>
+              </a:lnSpc>
+              <a:spcAft>
+                <a:spcPts val="0"/>
+              </a:spcAft>
+            </a:pPr>
+            <a:r>
+              <a:rPr sz="680" b="1" i="0">
+                <a:solidFill>
+                  <a:srgbClr val="314359"/>
+                </a:solidFill>
+                <a:latin typeface="Arial"/>
+              </a:rPr>
+              <a:t>Robit Plc — Nasdaq Helsinki. Invested in stages from May 2015; a niche drilling-consumables franchise below intrinsic value.</a:t>
+            </a:r>
+          </a:p>
+        </p:txBody>
+      </p:sp>
+      <p:sp>
+        <p:nvSpPr>
+          <p:cNvPr id="37" name="Rectangle 36"/>
+          <p:cNvSpPr/>
+          <p:nvPr/>
+        </p:nvSpPr>
+        <p:spPr>
+          <a:xfrm>
+            <a:off x="1938575" y="4389120"/>
+            <a:ext cx="1389922" cy="1511808"/>
+          </a:xfrm>
+          <a:prstGeom prst="rect">
+            <a:avLst/>
+          </a:prstGeom>
+          <a:solidFill>
+            <a:srgbClr val="FFFFFF"/>
+          </a:solidFill>
+          <a:ln>
+            <a:noFill/>
+          </a:ln>
+          <a:effectLst/>
+        </p:spPr>
+        <p:style>
+          <a:lnRef idx="1">
+            <a:schemeClr val="accent1"/>
+          </a:lnRef>
+          <a:fillRef idx="3">
+            <a:schemeClr val="accent1"/>
+          </a:fillRef>
+          <a:effectRef idx="2">
+            <a:schemeClr val="accent1"/>
+          </a:effectRef>
+          <a:fontRef idx="minor">
+            <a:schemeClr val="lt1"/>
+          </a:fontRef>
+        </p:style>
+        <p:txBody>
+          <a:bodyPr rtlCol="0" anchor="ctr"/>
+          <a:lstStyle/>
+          <a:p>
+            <a:pPr algn="ctr"/>
+          </a:p>
+        </p:txBody>
+      </p:sp>
+      <p:sp>
+        <p:nvSpPr>
+          <p:cNvPr id="38" name="TextBox 37"/>
+          <p:cNvSpPr txBox="1"/>
+          <p:nvPr/>
+        </p:nvSpPr>
+        <p:spPr>
+          <a:xfrm>
+            <a:off x="2033675" y="4486656"/>
+            <a:ext cx="1228984" cy="1336243"/>
+          </a:xfrm>
+          <a:prstGeom prst="rect">
+            <a:avLst/>
+          </a:prstGeom>
+          <a:noFill/>
+        </p:spPr>
+        <p:txBody>
+          <a:bodyPr wrap="square" anchor="t" lIns="0" rIns="0" tIns="0" bIns="0">
+            <a:spAutoFit/>
+          </a:bodyPr>
+          <a:lstStyle/>
+          <a:p>
+            <a:pPr algn="l">
+              <a:lnSpc>
+                <a:spcPct val="112000"/>
+              </a:lnSpc>
+              <a:spcAft>
+                <a:spcPts val="0"/>
+              </a:spcAft>
+            </a:pPr>
+            <a:r>
+              <a:rPr sz="680" b="0" i="0">
+                <a:solidFill>
+                  <a:srgbClr val="0E1620"/>
+                </a:solidFill>
+                <a:latin typeface="Arial"/>
+              </a:rPr>
+              <a:t>Board-level plan to fix the cost base and capital allocation.</a:t>
+            </a:r>
+          </a:p>
+        </p:txBody>
+      </p:sp>
+      <p:sp>
+        <p:nvSpPr>
+          <p:cNvPr id="39" name="Rectangle 38"/>
+          <p:cNvSpPr/>
+          <p:nvPr/>
+        </p:nvSpPr>
+        <p:spPr>
+          <a:xfrm>
+            <a:off x="3328498" y="4389120"/>
+            <a:ext cx="1463076" cy="1511808"/>
+          </a:xfrm>
+          <a:prstGeom prst="rect">
+            <a:avLst/>
+          </a:prstGeom>
+          <a:solidFill>
+            <a:srgbClr val="FFFFFF"/>
+          </a:solidFill>
+          <a:ln>
+            <a:noFill/>
+          </a:ln>
+          <a:effectLst/>
+        </p:spPr>
+        <p:style>
+          <a:lnRef idx="1">
+            <a:schemeClr val="accent1"/>
+          </a:lnRef>
+          <a:fillRef idx="3">
+            <a:schemeClr val="accent1"/>
+          </a:fillRef>
+          <a:effectRef idx="2">
+            <a:schemeClr val="accent1"/>
+          </a:effectRef>
+          <a:fontRef idx="minor">
+            <a:schemeClr val="lt1"/>
+          </a:fontRef>
+        </p:style>
+        <p:txBody>
+          <a:bodyPr rtlCol="0" anchor="ctr"/>
+          <a:lstStyle/>
+          <a:p>
+            <a:pPr algn="ctr"/>
+          </a:p>
+        </p:txBody>
+      </p:sp>
+      <p:sp>
+        <p:nvSpPr>
+          <p:cNvPr id="40" name="TextBox 39"/>
+          <p:cNvSpPr txBox="1"/>
+          <p:nvPr/>
+        </p:nvSpPr>
+        <p:spPr>
+          <a:xfrm>
+            <a:off x="3423598" y="4486656"/>
+            <a:ext cx="1302138" cy="1336243"/>
+          </a:xfrm>
+          <a:prstGeom prst="rect">
+            <a:avLst/>
+          </a:prstGeom>
+          <a:noFill/>
+        </p:spPr>
+        <p:txBody>
+          <a:bodyPr wrap="square" anchor="t" lIns="0" rIns="0" tIns="0" bIns="0">
+            <a:spAutoFit/>
+          </a:bodyPr>
+          <a:lstStyle/>
+          <a:p>
+            <a:pPr algn="l">
+              <a:lnSpc>
+                <a:spcPct val="112000"/>
+              </a:lnSpc>
+              <a:spcAft>
+                <a:spcPts val="0"/>
+              </a:spcAft>
+            </a:pPr>
+            <a:r>
+              <a:rPr sz="680" b="0" i="0">
+                <a:solidFill>
+                  <a:srgbClr val="0E1620"/>
+                </a:solidFill>
+                <a:latin typeface="Arial"/>
+              </a:rPr>
+              <a:t>From 2019 we sought a board seat to formalise the plan — and could not secure board alignment.</a:t>
+            </a:r>
+          </a:p>
+        </p:txBody>
+      </p:sp>
+      <p:sp>
+        <p:nvSpPr>
+          <p:cNvPr id="41" name="Rectangle 40"/>
+          <p:cNvSpPr/>
+          <p:nvPr/>
+        </p:nvSpPr>
+        <p:spPr>
+          <a:xfrm>
+            <a:off x="4791575" y="4389120"/>
+            <a:ext cx="1719115" cy="1511808"/>
+          </a:xfrm>
+          <a:prstGeom prst="rect">
+            <a:avLst/>
+          </a:prstGeom>
+          <a:solidFill>
+            <a:srgbClr val="FFFFFF"/>
+          </a:solidFill>
+          <a:ln>
+            <a:noFill/>
+          </a:ln>
+          <a:effectLst/>
+        </p:spPr>
+        <p:style>
+          <a:lnRef idx="1">
+            <a:schemeClr val="accent1"/>
+          </a:lnRef>
+          <a:fillRef idx="3">
+            <a:schemeClr val="accent1"/>
+          </a:fillRef>
+          <a:effectRef idx="2">
+            <a:schemeClr val="accent1"/>
+          </a:effectRef>
+          <a:fontRef idx="minor">
+            <a:schemeClr val="lt1"/>
+          </a:fontRef>
+        </p:style>
+        <p:txBody>
+          <a:bodyPr rtlCol="0" anchor="ctr"/>
+          <a:lstStyle/>
+          <a:p>
+            <a:pPr algn="ctr"/>
+          </a:p>
+        </p:txBody>
+      </p:sp>
+      <p:sp>
+        <p:nvSpPr>
+          <p:cNvPr id="42" name="TextBox 41"/>
+          <p:cNvSpPr txBox="1"/>
+          <p:nvPr/>
+        </p:nvSpPr>
+        <p:spPr>
+          <a:xfrm>
+            <a:off x="4886675" y="4486656"/>
+            <a:ext cx="1558176" cy="1336243"/>
+          </a:xfrm>
+          <a:prstGeom prst="rect">
+            <a:avLst/>
+          </a:prstGeom>
+          <a:noFill/>
+        </p:spPr>
+        <p:txBody>
+          <a:bodyPr wrap="square" anchor="t" lIns="0" rIns="0" tIns="0" bIns="0">
+            <a:spAutoFit/>
+          </a:bodyPr>
+          <a:lstStyle/>
+          <a:p>
+            <a:pPr algn="l">
+              <a:lnSpc>
+                <a:spcPct val="112000"/>
+              </a:lnSpc>
+              <a:spcAft>
+                <a:spcPts val="0"/>
+              </a:spcAft>
+            </a:pPr>
+            <a:r>
+              <a:rPr sz="680" b="0" i="0">
+                <a:solidFill>
+                  <a:srgbClr val="0E1620"/>
+                </a:solidFill>
+                <a:latin typeface="Arial"/>
+              </a:rPr>
+              <a:t>Walked away — unwound rather than stay without influence.</a:t>
+            </a:r>
+          </a:p>
+        </p:txBody>
+      </p:sp>
+      <p:sp>
+        <p:nvSpPr>
+          <p:cNvPr id="43" name="Rectangle 42"/>
+          <p:cNvSpPr/>
+          <p:nvPr/>
+        </p:nvSpPr>
+        <p:spPr>
+          <a:xfrm>
+            <a:off x="6510690" y="4389120"/>
+            <a:ext cx="1243615" cy="1511808"/>
+          </a:xfrm>
+          <a:prstGeom prst="rect">
+            <a:avLst/>
+          </a:prstGeom>
+          <a:solidFill>
+            <a:srgbClr val="FFFFFF"/>
+          </a:solidFill>
+          <a:ln>
+            <a:noFill/>
+          </a:ln>
+          <a:effectLst/>
+        </p:spPr>
+        <p:style>
+          <a:lnRef idx="1">
+            <a:schemeClr val="accent1"/>
+          </a:lnRef>
+          <a:fillRef idx="3">
+            <a:schemeClr val="accent1"/>
+          </a:fillRef>
+          <a:effectRef idx="2">
+            <a:schemeClr val="accent1"/>
+          </a:effectRef>
+          <a:fontRef idx="minor">
+            <a:schemeClr val="lt1"/>
+          </a:fontRef>
+        </p:style>
+        <p:txBody>
+          <a:bodyPr rtlCol="0" anchor="ctr"/>
+          <a:lstStyle/>
+          <a:p>
+            <a:pPr algn="ctr"/>
+          </a:p>
+        </p:txBody>
+      </p:sp>
+      <p:sp>
+        <p:nvSpPr>
+          <p:cNvPr id="44" name="TextBox 43"/>
+          <p:cNvSpPr txBox="1"/>
+          <p:nvPr/>
+        </p:nvSpPr>
+        <p:spPr>
+          <a:xfrm>
+            <a:off x="6605790" y="4486656"/>
+            <a:ext cx="1082676" cy="1336243"/>
+          </a:xfrm>
+          <a:prstGeom prst="rect">
+            <a:avLst/>
+          </a:prstGeom>
+          <a:noFill/>
+        </p:spPr>
+        <p:txBody>
+          <a:bodyPr wrap="square" anchor="t" lIns="0" rIns="0" tIns="0" bIns="0">
+            <a:spAutoFit/>
+          </a:bodyPr>
+          <a:lstStyle/>
+          <a:p>
+            <a:pPr algn="l">
+              <a:lnSpc>
+                <a:spcPct val="112000"/>
+              </a:lnSpc>
+              <a:spcAft>
+                <a:spcPts val="0"/>
+              </a:spcAft>
+            </a:pPr>
+            <a:r>
+              <a:rPr sz="680" b="0" i="0">
+                <a:solidFill>
+                  <a:srgbClr val="0E1620"/>
+                </a:solidFill>
+                <a:latin typeface="Arial"/>
+              </a:rPr>
+              <a:t>Exited at ~14% IRR (&gt;2× the index); the shares have since roughly halved.</a:t>
+            </a:r>
+          </a:p>
+        </p:txBody>
+      </p:sp>
+      <p:sp>
+        <p:nvSpPr>
+          <p:cNvPr id="45" name="Rectangle 44"/>
+          <p:cNvSpPr/>
+          <p:nvPr/>
+        </p:nvSpPr>
+        <p:spPr>
+          <a:xfrm>
+            <a:off x="7754305" y="4389120"/>
+            <a:ext cx="1536230" cy="1511808"/>
+          </a:xfrm>
+          <a:prstGeom prst="rect">
+            <a:avLst/>
+          </a:prstGeom>
+          <a:solidFill>
+            <a:srgbClr val="FFFFFF"/>
+          </a:solidFill>
+          <a:ln>
+            <a:noFill/>
+          </a:ln>
+          <a:effectLst/>
+        </p:spPr>
+        <p:style>
+          <a:lnRef idx="1">
+            <a:schemeClr val="accent1"/>
+          </a:lnRef>
+          <a:fillRef idx="3">
+            <a:schemeClr val="accent1"/>
+          </a:fillRef>
+          <a:effectRef idx="2">
+            <a:schemeClr val="accent1"/>
+          </a:effectRef>
+          <a:fontRef idx="minor">
+            <a:schemeClr val="lt1"/>
+          </a:fontRef>
+        </p:style>
+        <p:txBody>
+          <a:bodyPr rtlCol="0" anchor="ctr"/>
+          <a:lstStyle/>
+          <a:p>
+            <a:pPr algn="ctr"/>
+          </a:p>
+        </p:txBody>
+      </p:sp>
+      <p:sp>
+        <p:nvSpPr>
+          <p:cNvPr id="46" name="TextBox 45"/>
+          <p:cNvSpPr txBox="1"/>
+          <p:nvPr/>
+        </p:nvSpPr>
+        <p:spPr>
+          <a:xfrm>
+            <a:off x="7849405" y="4486656"/>
+            <a:ext cx="1375292" cy="1336243"/>
+          </a:xfrm>
+          <a:prstGeom prst="rect">
+            <a:avLst/>
+          </a:prstGeom>
+          <a:noFill/>
+        </p:spPr>
+        <p:txBody>
+          <a:bodyPr wrap="square" anchor="t" lIns="0" rIns="0" tIns="0" bIns="0">
+            <a:spAutoFit/>
+          </a:bodyPr>
+          <a:lstStyle/>
+          <a:p>
+            <a:pPr algn="l">
+              <a:lnSpc>
+                <a:spcPct val="112000"/>
+              </a:lnSpc>
+              <a:spcAft>
+                <a:spcPts val="0"/>
+              </a:spcAft>
+            </a:pPr>
+            <a:r>
+              <a:rPr sz="680" b="0" i="0">
+                <a:solidFill>
+                  <a:srgbClr val="0E1620"/>
+                </a:solidFill>
+                <a:latin typeface="Arial"/>
+              </a:rPr>
+              <a:t>Reinforced agreement-before-capital: no board alignment, no position.</a:t>
+            </a:r>
+          </a:p>
+        </p:txBody>
+      </p:sp>
+      <p:sp>
+        <p:nvSpPr>
+          <p:cNvPr id="47" name="TextBox 46"/>
+          <p:cNvSpPr txBox="1"/>
+          <p:nvPr/>
+        </p:nvSpPr>
+        <p:spPr>
+          <a:xfrm>
+            <a:off x="438922" y="5978956"/>
+            <a:ext cx="8851613" cy="292608"/>
+          </a:xfrm>
+          <a:prstGeom prst="rect">
+            <a:avLst/>
+          </a:prstGeom>
+          <a:noFill/>
+        </p:spPr>
+        <p:txBody>
+          <a:bodyPr wrap="square" anchor="t" lIns="0" rIns="0" tIns="0" bIns="0">
             <a:spAutoFit/>
           </a:bodyPr>
           <a:lstStyle/>
@@ -3851,13 +5035,99 @@
               </a:spcAft>
             </a:pPr>
             <a:r>
-              <a:rPr sz="1000" b="0" i="1">
+              <a:rPr sz="640" b="0" i="1">
+                <a:solidFill>
+                  <a:srgbClr val="556A83"/>
+                </a:solidFill>
+                <a:latin typeface="Arial"/>
+              </a:rPr>
+              <a:t>Two entries shown; further cases to be added. The system is not static — Robit shaped “agreement before capital,” DistIT built the determined-seller exit.</a:t>
+            </a:r>
+          </a:p>
+        </p:txBody>
+      </p:sp>
+      <p:sp>
+        <p:nvSpPr>
+          <p:cNvPr id="48" name="Rectangle 47"/>
+          <p:cNvSpPr/>
+          <p:nvPr/>
+        </p:nvSpPr>
+        <p:spPr>
+          <a:xfrm>
+            <a:off x="438922" y="6242304"/>
+            <a:ext cx="8895505" cy="585216"/>
+          </a:xfrm>
+          <a:prstGeom prst="rect">
+            <a:avLst/>
+          </a:prstGeom>
+          <a:solidFill>
+            <a:srgbClr val="152130"/>
+          </a:solidFill>
+          <a:ln>
+            <a:noFill/>
+          </a:ln>
+          <a:effectLst/>
+        </p:spPr>
+        <p:style>
+          <a:lnRef idx="1">
+            <a:schemeClr val="accent1"/>
+          </a:lnRef>
+          <a:fillRef idx="3">
+            <a:schemeClr val="accent1"/>
+          </a:fillRef>
+          <a:effectRef idx="2">
+            <a:schemeClr val="accent1"/>
+          </a:effectRef>
+          <a:fontRef idx="minor">
+            <a:schemeClr val="lt1"/>
+          </a:fontRef>
+        </p:style>
+        <p:txBody>
+          <a:bodyPr rtlCol="0" anchor="ctr"/>
+          <a:lstStyle/>
+          <a:p>
+            <a:pPr algn="ctr"/>
+          </a:p>
+        </p:txBody>
+      </p:sp>
+      <p:sp>
+        <p:nvSpPr>
+          <p:cNvPr id="49" name="TextBox 48"/>
+          <p:cNvSpPr txBox="1"/>
+          <p:nvPr/>
+        </p:nvSpPr>
+        <p:spPr>
+          <a:xfrm>
+            <a:off x="585230" y="6242304"/>
+            <a:ext cx="8632151" cy="585216"/>
+          </a:xfrm>
+          <a:prstGeom prst="rect">
+            <a:avLst/>
+          </a:prstGeom>
+          <a:noFill/>
+        </p:spPr>
+        <p:txBody>
+          <a:bodyPr wrap="square" anchor="ctr" lIns="0" rIns="0" tIns="0" bIns="0">
+            <a:spAutoFit/>
+          </a:bodyPr>
+          <a:lstStyle/>
+          <a:p>
+            <a:pPr algn="l">
+              <a:lnSpc>
+                <a:spcPct val="110000"/>
+              </a:lnSpc>
+              <a:spcAft>
+                <a:spcPts val="0"/>
+              </a:spcAft>
+            </a:pPr>
+            <a:r>
+              <a:rPr sz="960" b="0" i="1">
                 <a:solidFill>
                   <a:srgbClr val="FFFFFF"/>
                 </a:solidFill>
                 <a:latin typeface="Arial"/>
               </a:rPr>
-              <a:t>Conviction to build, the discipline to exit, and the honesty to systematise our own mistakes — both cases protected capital, and made the risk system better.</a:t>
+              <a:t>A risk system we both use and keep building — every engagement tests it, and our own mistakes are written back into it.</a:t>
             </a:r>
           </a:p>
         </p:txBody>

</xml_diff>